<commit_message>
Embed architecture diagram into research deck slide 5
Slide 5 now shows arch_diagram.png (full-width) with the gate equation
and all 5 variant formulas (A-D + proposed) in a panel below.

Co-Authored-By: Claude Sonnet 4.6 <noreply@anthropic.com>
</commit_message>
<xml_diff>
--- a/full_research_deck.pptx
+++ b/full_research_deck.pptx
@@ -9336,8 +9336,8 @@
         </p:nvSpPr>
         <p:spPr>
           <a:xfrm>
-            <a:off x="502920" y="128016"/>
-            <a:ext cx="11338560" cy="548640"/>
+            <a:off x="502920" y="109728"/>
+            <a:ext cx="11338560" cy="502920"/>
           </a:xfrm>
           <a:prstGeom prst="rect">
             <a:avLst/>
@@ -9357,7 +9357,7 @@
                   <a:srgbClr val="FFFFFF"/>
                 </a:solidFill>
               </a:rPr>
-              <a:t>Proposed Method  —  Trust-Gated Aggregation</a:t>
+              <a:t>Proposed Method  —  Trust-Gated Architecture</a:t>
             </a:r>
           </a:p>
         </p:txBody>
@@ -9370,28 +9370,28 @@
         </p:nvSpPr>
         <p:spPr>
           <a:xfrm>
-            <a:off x="502920" y="685800"/>
-            <a:ext cx="11338560" cy="320040"/>
-          </a:xfrm>
-          <a:prstGeom prst="rect">
-            <a:avLst/>
-          </a:prstGeom>
-          <a:noFill/>
-        </p:spPr>
-        <p:txBody>
-          <a:bodyPr wrap="square">
-            <a:spAutoFit/>
-          </a:bodyPr>
-          <a:lstStyle/>
-          <a:p>
-            <a:pPr algn="l"/>
-            <a:r>
-              <a:rPr sz="1200" b="0" i="0">
+            <a:off x="502920" y="658368"/>
+            <a:ext cx="11338560" cy="292608"/>
+          </a:xfrm>
+          <a:prstGeom prst="rect">
+            <a:avLst/>
+          </a:prstGeom>
+          <a:noFill/>
+        </p:spPr>
+        <p:txBody>
+          <a:bodyPr wrap="square">
+            <a:spAutoFit/>
+          </a:bodyPr>
+          <a:lstStyle/>
+          <a:p>
+            <a:pPr algn="l"/>
+            <a:r>
+              <a:rPr sz="1150" b="0" i="0">
                 <a:solidFill>
                   <a:srgbClr val="8A93A8"/>
                 </a:solidFill>
               </a:rPr>
-              <a:t>Per-node gate β_v driven by LLM semantic reliability judgment</a:t>
+              <a:t>Trust gate taps e_v BEFORE VQ quantization — cleaner semantic signal than STEM-GNN's post-VQ router</a:t>
             </a:r>
           </a:p>
         </p:txBody>
@@ -9404,7 +9404,7 @@
         </p:nvCxnSpPr>
         <p:spPr>
           <a:xfrm>
-            <a:off x="502920" y="1033271"/>
+            <a:off x="502920" y="1005840"/>
             <a:ext cx="11183112" cy="0"/>
           </a:xfrm>
           <a:prstGeom prst="line">
@@ -9431,16 +9431,40 @@
           </a:fontRef>
         </p:style>
       </p:cxnSp>
-      <p:sp>
-        <p:nvSpPr>
-          <p:cNvPr id="7" name="Rectangle 6"/>
+      <p:pic>
+        <p:nvPicPr>
+          <p:cNvPr id="7" name="Picture 6" descr="arch_diagram.png"/>
+          <p:cNvPicPr>
+            <a:picLocks noChangeAspect="1"/>
+          </p:cNvPicPr>
+          <p:nvPr/>
+        </p:nvPicPr>
+        <p:blipFill>
+          <a:blip r:embed="rId2"/>
+          <a:stretch>
+            <a:fillRect/>
+          </a:stretch>
+        </p:blipFill>
+        <p:spPr>
+          <a:xfrm>
+            <a:off x="365760" y="1078992"/>
+            <a:ext cx="11475720" cy="3767328"/>
+          </a:xfrm>
+          <a:prstGeom prst="rect">
+            <a:avLst/>
+          </a:prstGeom>
+        </p:spPr>
+      </p:pic>
+      <p:sp>
+        <p:nvSpPr>
+          <p:cNvPr id="8" name="Rectangle 7"/>
           <p:cNvSpPr/>
           <p:nvPr/>
         </p:nvSpPr>
         <p:spPr>
           <a:xfrm>
-            <a:off x="411480" y="1234440"/>
-            <a:ext cx="2240280" cy="2011680"/>
+            <a:off x="365760" y="4956048"/>
+            <a:ext cx="11475720" cy="1764792"/>
           </a:xfrm>
           <a:prstGeom prst="rect">
             <a:avLst/>
@@ -9448,9 +9472,9 @@
           <a:solidFill>
             <a:srgbClr val="101420"/>
           </a:solidFill>
-          <a:ln w="19050">
+          <a:ln w="10160">
             <a:solidFill>
-              <a:srgbClr val="8A93A8"/>
+              <a:srgbClr val="353C50"/>
             </a:solidFill>
           </a:ln>
         </p:spPr>
@@ -9478,85 +9502,14 @@
       </p:sp>
       <p:sp>
         <p:nvSpPr>
-          <p:cNvPr id="8" name="TextBox 7"/>
-          <p:cNvSpPr txBox="1"/>
-          <p:nvPr/>
-        </p:nvSpPr>
-        <p:spPr>
-          <a:xfrm>
-            <a:off x="521208" y="1325880"/>
-            <a:ext cx="2057400" cy="347472"/>
-          </a:xfrm>
-          <a:prstGeom prst="rect">
-            <a:avLst/>
-          </a:prstGeom>
-          <a:noFill/>
-        </p:spPr>
-        <p:txBody>
-          <a:bodyPr wrap="square">
-            <a:spAutoFit/>
-          </a:bodyPr>
-          <a:lstStyle/>
-          <a:p>
-            <a:pPr algn="l"/>
-            <a:r>
-              <a:rPr sz="1200" b="1" i="0">
-                <a:solidFill>
-                  <a:srgbClr val="8A93A8"/>
-                </a:solidFill>
-              </a:rPr>
-              <a:t>Text
-Attributes</a:t>
-            </a:r>
-          </a:p>
-        </p:txBody>
-      </p:sp>
-      <p:sp>
-        <p:nvSpPr>
           <p:cNvPr id="9" name="TextBox 8"/>
           <p:cNvSpPr txBox="1"/>
           <p:nvPr/>
         </p:nvSpPr>
         <p:spPr>
           <a:xfrm>
-            <a:off x="521208" y="1709928"/>
-            <a:ext cx="2057400" cy="1463040"/>
-          </a:xfrm>
-          <a:prstGeom prst="rect">
-            <a:avLst/>
-          </a:prstGeom>
-          <a:noFill/>
-        </p:spPr>
-        <p:txBody>
-          <a:bodyPr wrap="square">
-            <a:spAutoFit/>
-          </a:bodyPr>
-          <a:lstStyle/>
-          <a:p>
-            <a:pPr algn="l"/>
-            <a:r>
-              <a:rPr sz="980" b="0" i="0">
-                <a:solidFill>
-                  <a:srgbClr val="FFFFFF"/>
-                </a:solidFill>
-              </a:rPr>
-              <a:t>t_v for each node v
-(raw sentences,
-abstracts, etc.)</a:t>
-            </a:r>
-          </a:p>
-        </p:txBody>
-      </p:sp>
-      <p:sp>
-        <p:nvSpPr>
-          <p:cNvPr id="10" name="TextBox 9"/>
-          <p:cNvSpPr txBox="1"/>
-          <p:nvPr/>
-        </p:nvSpPr>
-        <p:spPr>
-          <a:xfrm>
-            <a:off x="2697480" y="1965960"/>
-            <a:ext cx="411480" cy="548640"/>
+            <a:off x="548640" y="5047488"/>
+            <a:ext cx="11155680" cy="438912"/>
           </a:xfrm>
           <a:prstGeom prst="rect">
             <a:avLst/>
@@ -9571,16 +9524,51 @@
           <a:p>
             <a:pPr algn="ctr"/>
             <a:r>
-              <a:rPr sz="2200" b="1" i="0">
-                <a:solidFill>
-                  <a:srgbClr val="8A93A8"/>
-                </a:solidFill>
-              </a:rPr>
-              <a:t>→</a:t>
-            </a:r>
-          </a:p>
-        </p:txBody>
-      </p:sp>
+              <a:rPr sz="1450" b="1" i="0">
+                <a:solidFill>
+                  <a:srgbClr val="45C4FF"/>
+                </a:solidFill>
+              </a:rPr>
+              <a:t>h_v  =  β_v · W_self(e_v)  +  (1 − β_v) · W_neigh( MEAN{ e_u : u ∈ N(v) } )</a:t>
+            </a:r>
+          </a:p>
+        </p:txBody>
+      </p:sp>
+      <p:cxnSp>
+        <p:nvCxnSpPr>
+          <p:cNvPr id="10" name="Connector 9"/>
+          <p:cNvCxnSpPr/>
+          <p:nvPr/>
+        </p:nvCxnSpPr>
+        <p:spPr>
+          <a:xfrm>
+            <a:off x="548640" y="5532120"/>
+            <a:ext cx="11137392" cy="0"/>
+          </a:xfrm>
+          <a:prstGeom prst="line">
+            <a:avLst/>
+          </a:prstGeom>
+          <a:ln w="7620">
+            <a:solidFill>
+              <a:srgbClr val="353C50"/>
+            </a:solidFill>
+          </a:ln>
+        </p:spPr>
+        <p:style>
+          <a:lnRef idx="2">
+            <a:schemeClr val="accent1"/>
+          </a:lnRef>
+          <a:fillRef idx="0">
+            <a:schemeClr val="accent1"/>
+          </a:fillRef>
+          <a:effectRef idx="1">
+            <a:schemeClr val="accent1"/>
+          </a:effectRef>
+          <a:fontRef idx="minor">
+            <a:schemeClr val="tx1"/>
+          </a:fontRef>
+        </p:style>
+      </p:cxnSp>
       <p:sp>
         <p:nvSpPr>
           <p:cNvPr id="11" name="Rectangle 10"/>
@@ -9589,19 +9577,17 @@
         </p:nvSpPr>
         <p:spPr>
           <a:xfrm>
-            <a:off x="2788920" y="1234440"/>
-            <a:ext cx="2240280" cy="2011680"/>
+            <a:off x="502920" y="5596128"/>
+            <a:ext cx="54864" cy="1051560"/>
           </a:xfrm>
           <a:prstGeom prst="rect">
             <a:avLst/>
           </a:prstGeom>
           <a:solidFill>
-            <a:srgbClr val="101420"/>
+            <a:srgbClr val="FF4D4D"/>
           </a:solidFill>
-          <a:ln w="19050">
-            <a:solidFill>
-              <a:srgbClr val="459BFF"/>
-            </a:solidFill>
+          <a:ln>
+            <a:noFill/>
           </a:ln>
         </p:spPr>
         <p:style>
@@ -9634,29 +9620,28 @@
         </p:nvSpPr>
         <p:spPr>
           <a:xfrm>
-            <a:off x="2898648" y="1325880"/>
-            <a:ext cx="2057400" cy="347472"/>
-          </a:xfrm>
-          <a:prstGeom prst="rect">
-            <a:avLst/>
-          </a:prstGeom>
-          <a:noFill/>
-        </p:spPr>
-        <p:txBody>
-          <a:bodyPr wrap="square">
-            <a:spAutoFit/>
-          </a:bodyPr>
-          <a:lstStyle/>
-          <a:p>
-            <a:pPr algn="l"/>
-            <a:r>
-              <a:rPr sz="1200" b="1" i="0">
-                <a:solidFill>
-                  <a:srgbClr val="459BFF"/>
-                </a:solidFill>
-              </a:rPr>
-              <a:t>LLM Encoder
-φ (frozen)</a:t>
+            <a:off x="612648" y="5596128"/>
+            <a:ext cx="2176272" cy="310896"/>
+          </a:xfrm>
+          <a:prstGeom prst="rect">
+            <a:avLst/>
+          </a:prstGeom>
+          <a:noFill/>
+        </p:spPr>
+        <p:txBody>
+          <a:bodyPr wrap="square">
+            <a:spAutoFit/>
+          </a:bodyPr>
+          <a:lstStyle/>
+          <a:p>
+            <a:pPr algn="l"/>
+            <a:r>
+              <a:rPr sz="1000" b="1" i="0">
+                <a:solidFill>
+                  <a:srgbClr val="FF4D4D"/>
+                </a:solidFill>
+              </a:rPr>
+              <a:t>A  Cosine</a:t>
             </a:r>
           </a:p>
         </p:txBody>
@@ -9669,89 +9654,51 @@
         </p:nvSpPr>
         <p:spPr>
           <a:xfrm>
-            <a:off x="2898648" y="1709928"/>
-            <a:ext cx="2057400" cy="1463040"/>
-          </a:xfrm>
-          <a:prstGeom prst="rect">
-            <a:avLst/>
-          </a:prstGeom>
-          <a:noFill/>
-        </p:spPr>
-        <p:txBody>
-          <a:bodyPr wrap="square">
-            <a:spAutoFit/>
-          </a:bodyPr>
-          <a:lstStyle/>
-          <a:p>
-            <a:pPr algn="l"/>
-            <a:r>
-              <a:rPr sz="980" b="0" i="0">
+            <a:off x="612648" y="5925312"/>
+            <a:ext cx="2176272" cy="749808"/>
+          </a:xfrm>
+          <a:prstGeom prst="rect">
+            <a:avLst/>
+          </a:prstGeom>
+          <a:noFill/>
+        </p:spPr>
+        <p:txBody>
+          <a:bodyPr wrap="square">
+            <a:spAutoFit/>
+          </a:bodyPr>
+          <a:lstStyle/>
+          <a:p>
+            <a:pPr algn="l"/>
+            <a:r>
+              <a:rPr sz="880" b="0" i="1">
                 <a:solidFill>
                   <a:srgbClr val="FFFFFF"/>
                 </a:solidFill>
               </a:rPr>
-              <a:t>e_v = φ(t_v) ∈ ℝ^768
-SentenceTransformer
-or any encoder</a:t>
-            </a:r>
-          </a:p>
-        </p:txBody>
-      </p:sp>
-      <p:sp>
-        <p:nvSpPr>
-          <p:cNvPr id="14" name="TextBox 13"/>
-          <p:cNvSpPr txBox="1"/>
-          <p:nvPr/>
-        </p:nvSpPr>
-        <p:spPr>
-          <a:xfrm>
-            <a:off x="5074920" y="1965960"/>
-            <a:ext cx="411480" cy="548640"/>
-          </a:xfrm>
-          <a:prstGeom prst="rect">
-            <a:avLst/>
-          </a:prstGeom>
-          <a:noFill/>
-        </p:spPr>
-        <p:txBody>
-          <a:bodyPr wrap="square">
-            <a:spAutoFit/>
-          </a:bodyPr>
-          <a:lstStyle/>
-          <a:p>
-            <a:pPr algn="ctr"/>
-            <a:r>
-              <a:rPr sz="2200" b="1" i="0">
-                <a:solidFill>
-                  <a:srgbClr val="8A93A8"/>
-                </a:solidFill>
-              </a:rPr>
-              <a:t>→</a:t>
-            </a:r>
-          </a:p>
-        </p:txBody>
-      </p:sp>
-      <p:sp>
-        <p:nvSpPr>
-          <p:cNvPr id="15" name="Rectangle 14"/>
+              <a:t>1 − σ(cos(h_v, mean h_u))</a:t>
+            </a:r>
+          </a:p>
+        </p:txBody>
+      </p:sp>
+      <p:sp>
+        <p:nvSpPr>
+          <p:cNvPr id="14" name="Rectangle 13"/>
           <p:cNvSpPr/>
           <p:nvPr/>
         </p:nvSpPr>
         <p:spPr>
           <a:xfrm>
-            <a:off x="5166360" y="1234440"/>
-            <a:ext cx="2240280" cy="2011680"/>
+            <a:off x="2825496" y="5596128"/>
+            <a:ext cx="54864" cy="1051560"/>
           </a:xfrm>
           <a:prstGeom prst="rect">
             <a:avLst/>
           </a:prstGeom>
           <a:solidFill>
-            <a:srgbClr val="101420"/>
+            <a:srgbClr val="FF7F2A"/>
           </a:solidFill>
-          <a:ln w="19050">
-            <a:solidFill>
-              <a:srgbClr val="45C4FF"/>
-            </a:solidFill>
+          <a:ln>
+            <a:noFill/>
           </a:ln>
         </p:spPr>
         <p:style>
@@ -9778,131 +9725,91 @@
       </p:sp>
       <p:sp>
         <p:nvSpPr>
+          <p:cNvPr id="15" name="TextBox 14"/>
+          <p:cNvSpPr txBox="1"/>
+          <p:nvPr/>
+        </p:nvSpPr>
+        <p:spPr>
+          <a:xfrm>
+            <a:off x="2935224" y="5596128"/>
+            <a:ext cx="2176272" cy="310896"/>
+          </a:xfrm>
+          <a:prstGeom prst="rect">
+            <a:avLst/>
+          </a:prstGeom>
+          <a:noFill/>
+        </p:spPr>
+        <p:txBody>
+          <a:bodyPr wrap="square">
+            <a:spAutoFit/>
+          </a:bodyPr>
+          <a:lstStyle/>
+          <a:p>
+            <a:pPr algn="l"/>
+            <a:r>
+              <a:rPr sz="1000" b="1" i="0">
+                <a:solidFill>
+                  <a:srgbClr val="FF7F2A"/>
+                </a:solidFill>
+              </a:rPr>
+              <a:t>B  Confidence</a:t>
+            </a:r>
+          </a:p>
+        </p:txBody>
+      </p:sp>
+      <p:sp>
+        <p:nvSpPr>
           <p:cNvPr id="16" name="TextBox 15"/>
           <p:cNvSpPr txBox="1"/>
           <p:nvPr/>
         </p:nvSpPr>
         <p:spPr>
           <a:xfrm>
-            <a:off x="5276088" y="1325880"/>
-            <a:ext cx="2057400" cy="347472"/>
-          </a:xfrm>
-          <a:prstGeom prst="rect">
-            <a:avLst/>
-          </a:prstGeom>
-          <a:noFill/>
-        </p:spPr>
-        <p:txBody>
-          <a:bodyPr wrap="square">
-            <a:spAutoFit/>
-          </a:bodyPr>
-          <a:lstStyle/>
-          <a:p>
-            <a:pPr algn="l"/>
-            <a:r>
-              <a:rPr sz="1200" b="1" i="0">
-                <a:solidFill>
-                  <a:srgbClr val="45C4FF"/>
-                </a:solidFill>
-              </a:rPr>
-              <a:t>Gate Signal
-β_v</a:t>
-            </a:r>
-          </a:p>
-        </p:txBody>
-      </p:sp>
-      <p:sp>
-        <p:nvSpPr>
-          <p:cNvPr id="17" name="TextBox 16"/>
-          <p:cNvSpPr txBox="1"/>
-          <p:nvPr/>
-        </p:nvSpPr>
-        <p:spPr>
-          <a:xfrm>
-            <a:off x="5276088" y="1709928"/>
-            <a:ext cx="2057400" cy="1463040"/>
-          </a:xfrm>
-          <a:prstGeom prst="rect">
-            <a:avLst/>
-          </a:prstGeom>
-          <a:noFill/>
-        </p:spPr>
-        <p:txBody>
-          <a:bodyPr wrap="square">
-            <a:spAutoFit/>
-          </a:bodyPr>
-          <a:lstStyle/>
-          <a:p>
-            <a:pPr algn="l"/>
-            <a:r>
-              <a:rPr sz="980" b="0" i="0">
+            <a:off x="2935224" y="5925312"/>
+            <a:ext cx="2176272" cy="749808"/>
+          </a:xfrm>
+          <a:prstGeom prst="rect">
+            <a:avLst/>
+          </a:prstGeom>
+          <a:noFill/>
+        </p:spPr>
+        <p:txBody>
+          <a:bodyPr wrap="square">
+            <a:spAutoFit/>
+          </a:bodyPr>
+          <a:lstStyle/>
+          <a:p>
+            <a:pPr algn="l"/>
+            <a:r>
+              <a:rPr sz="880" b="0" i="1">
                 <a:solidFill>
                   <a:srgbClr val="FFFFFF"/>
                 </a:solidFill>
               </a:rPr>
-              <a:t>Query LLM:
-'Is u semantically
-relevant for v?'
-β_v ∈ [0, 1]</a:t>
-            </a:r>
-          </a:p>
-        </p:txBody>
-      </p:sp>
-      <p:sp>
-        <p:nvSpPr>
-          <p:cNvPr id="18" name="TextBox 17"/>
-          <p:cNvSpPr txBox="1"/>
-          <p:nvPr/>
-        </p:nvSpPr>
-        <p:spPr>
-          <a:xfrm>
-            <a:off x="7452360" y="1965960"/>
-            <a:ext cx="411480" cy="548640"/>
-          </a:xfrm>
-          <a:prstGeom prst="rect">
-            <a:avLst/>
-          </a:prstGeom>
-          <a:noFill/>
-        </p:spPr>
-        <p:txBody>
-          <a:bodyPr wrap="square">
-            <a:spAutoFit/>
-          </a:bodyPr>
-          <a:lstStyle/>
-          <a:p>
-            <a:pPr algn="ctr"/>
-            <a:r>
-              <a:rPr sz="2200" b="1" i="0">
-                <a:solidFill>
-                  <a:srgbClr val="8A93A8"/>
-                </a:solidFill>
-              </a:rPr>
-              <a:t>→</a:t>
-            </a:r>
-          </a:p>
-        </p:txBody>
-      </p:sp>
-      <p:sp>
-        <p:nvSpPr>
-          <p:cNvPr id="19" name="Rectangle 18"/>
+              <a:t>1 − mean[max softmax(logits_u)]</a:t>
+            </a:r>
+          </a:p>
+        </p:txBody>
+      </p:sp>
+      <p:sp>
+        <p:nvSpPr>
+          <p:cNvPr id="17" name="Rectangle 16"/>
           <p:cNvSpPr/>
           <p:nvPr/>
         </p:nvSpPr>
         <p:spPr>
           <a:xfrm>
-            <a:off x="7543800" y="1234440"/>
-            <a:ext cx="2240280" cy="2011680"/>
+            <a:off x="5148072" y="5596128"/>
+            <a:ext cx="54864" cy="1051560"/>
           </a:xfrm>
           <a:prstGeom prst="rect">
             <a:avLst/>
           </a:prstGeom>
           <a:solidFill>
-            <a:srgbClr val="101420"/>
+            <a:srgbClr val="A06CFF"/>
           </a:solidFill>
-          <a:ln w="19050">
-            <a:solidFill>
-              <a:srgbClr val="2ECC71"/>
-            </a:solidFill>
+          <a:ln>
+            <a:noFill/>
           </a:ln>
         </p:spPr>
         <p:style>
@@ -9929,130 +9836,91 @@
       </p:sp>
       <p:sp>
         <p:nvSpPr>
-          <p:cNvPr id="20" name="TextBox 19"/>
-          <p:cNvSpPr txBox="1"/>
-          <p:nvPr/>
-        </p:nvSpPr>
-        <p:spPr>
-          <a:xfrm>
-            <a:off x="7653528" y="1325880"/>
-            <a:ext cx="2057400" cy="347472"/>
-          </a:xfrm>
-          <a:prstGeom prst="rect">
-            <a:avLst/>
-          </a:prstGeom>
-          <a:noFill/>
-        </p:spPr>
-        <p:txBody>
-          <a:bodyPr wrap="square">
-            <a:spAutoFit/>
-          </a:bodyPr>
-          <a:lstStyle/>
-          <a:p>
-            <a:pPr algn="l"/>
-            <a:r>
-              <a:rPr sz="1200" b="1" i="0">
-                <a:solidFill>
-                  <a:srgbClr val="2ECC71"/>
-                </a:solidFill>
-              </a:rPr>
-              <a:t>Gated
-Aggregation</a:t>
-            </a:r>
-          </a:p>
-        </p:txBody>
-      </p:sp>
-      <p:sp>
-        <p:nvSpPr>
-          <p:cNvPr id="21" name="TextBox 20"/>
-          <p:cNvSpPr txBox="1"/>
-          <p:nvPr/>
-        </p:nvSpPr>
-        <p:spPr>
-          <a:xfrm>
-            <a:off x="7653528" y="1709928"/>
-            <a:ext cx="2057400" cy="1463040"/>
-          </a:xfrm>
-          <a:prstGeom prst="rect">
-            <a:avLst/>
-          </a:prstGeom>
-          <a:noFill/>
-        </p:spPr>
-        <p:txBody>
-          <a:bodyPr wrap="square">
-            <a:spAutoFit/>
-          </a:bodyPr>
-          <a:lstStyle/>
-          <a:p>
-            <a:pPr algn="l"/>
-            <a:r>
-              <a:rPr sz="980" b="0" i="0">
+          <p:cNvPr id="18" name="TextBox 17"/>
+          <p:cNvSpPr txBox="1"/>
+          <p:nvPr/>
+        </p:nvSpPr>
+        <p:spPr>
+          <a:xfrm>
+            <a:off x="5257800" y="5596128"/>
+            <a:ext cx="2176272" cy="310896"/>
+          </a:xfrm>
+          <a:prstGeom prst="rect">
+            <a:avLst/>
+          </a:prstGeom>
+          <a:noFill/>
+        </p:spPr>
+        <p:txBody>
+          <a:bodyPr wrap="square">
+            <a:spAutoFit/>
+          </a:bodyPr>
+          <a:lstStyle/>
+          <a:p>
+            <a:pPr algn="l"/>
+            <a:r>
+              <a:rPr sz="1000" b="1" i="0">
+                <a:solidFill>
+                  <a:srgbClr val="A06CFF"/>
+                </a:solidFill>
+              </a:rPr>
+              <a:t>C  Learned</a:t>
+            </a:r>
+          </a:p>
+        </p:txBody>
+      </p:sp>
+      <p:sp>
+        <p:nvSpPr>
+          <p:cNvPr id="19" name="TextBox 18"/>
+          <p:cNvSpPr txBox="1"/>
+          <p:nvPr/>
+        </p:nvSpPr>
+        <p:spPr>
+          <a:xfrm>
+            <a:off x="5257800" y="5925312"/>
+            <a:ext cx="2176272" cy="749808"/>
+          </a:xfrm>
+          <a:prstGeom prst="rect">
+            <a:avLst/>
+          </a:prstGeom>
+          <a:noFill/>
+        </p:spPr>
+        <p:txBody>
+          <a:bodyPr wrap="square">
+            <a:spAutoFit/>
+          </a:bodyPr>
+          <a:lstStyle/>
+          <a:p>
+            <a:pPr algn="l"/>
+            <a:r>
+              <a:rPr sz="880" b="0" i="1">
                 <a:solidFill>
                   <a:srgbClr val="FFFFFF"/>
                 </a:solidFill>
               </a:rPr>
-              <a:t>h_v = β_v·W_self(e_v)
-+ (1−β_v)·W_neigh
-(mean e_u)</a:t>
-            </a:r>
-          </a:p>
-        </p:txBody>
-      </p:sp>
-      <p:sp>
-        <p:nvSpPr>
-          <p:cNvPr id="22" name="TextBox 21"/>
-          <p:cNvSpPr txBox="1"/>
-          <p:nvPr/>
-        </p:nvSpPr>
-        <p:spPr>
-          <a:xfrm>
-            <a:off x="9829800" y="1965960"/>
-            <a:ext cx="411480" cy="548640"/>
-          </a:xfrm>
-          <a:prstGeom prst="rect">
-            <a:avLst/>
-          </a:prstGeom>
-          <a:noFill/>
-        </p:spPr>
-        <p:txBody>
-          <a:bodyPr wrap="square">
-            <a:spAutoFit/>
-          </a:bodyPr>
-          <a:lstStyle/>
-          <a:p>
-            <a:pPr algn="ctr"/>
-            <a:r>
-              <a:rPr sz="2200" b="1" i="0">
-                <a:solidFill>
-                  <a:srgbClr val="8A93A8"/>
-                </a:solidFill>
-              </a:rPr>
-              <a:t>→</a:t>
-            </a:r>
-          </a:p>
-        </p:txBody>
-      </p:sp>
-      <p:sp>
-        <p:nvSpPr>
-          <p:cNvPr id="23" name="Rectangle 22"/>
+              <a:t>MLP(e_v ‖ mean e_u).sigmoid()</a:t>
+            </a:r>
+          </a:p>
+        </p:txBody>
+      </p:sp>
+      <p:sp>
+        <p:nvSpPr>
+          <p:cNvPr id="20" name="Rectangle 19"/>
           <p:cNvSpPr/>
           <p:nvPr/>
         </p:nvSpPr>
         <p:spPr>
           <a:xfrm>
-            <a:off x="9921240" y="1234440"/>
-            <a:ext cx="2240280" cy="2011680"/>
+            <a:off x="7470648" y="5596128"/>
+            <a:ext cx="54864" cy="1051560"/>
           </a:xfrm>
           <a:prstGeom prst="rect">
             <a:avLst/>
           </a:prstGeom>
           <a:solidFill>
-            <a:srgbClr val="101420"/>
+            <a:srgbClr val="45C4FF"/>
           </a:solidFill>
-          <a:ln w="19050">
-            <a:solidFill>
-              <a:srgbClr val="FFC107"/>
-            </a:solidFill>
+          <a:ln>
+            <a:noFill/>
           </a:ln>
         </p:spPr>
         <p:style>
@@ -10079,96 +9947,91 @@
       </p:sp>
       <p:sp>
         <p:nvSpPr>
-          <p:cNvPr id="24" name="TextBox 23"/>
-          <p:cNvSpPr txBox="1"/>
-          <p:nvPr/>
-        </p:nvSpPr>
-        <p:spPr>
-          <a:xfrm>
-            <a:off x="10030968" y="1325880"/>
-            <a:ext cx="2057400" cy="347472"/>
-          </a:xfrm>
-          <a:prstGeom prst="rect">
-            <a:avLst/>
-          </a:prstGeom>
-          <a:noFill/>
-        </p:spPr>
-        <p:txBody>
-          <a:bodyPr wrap="square">
-            <a:spAutoFit/>
-          </a:bodyPr>
-          <a:lstStyle/>
-          <a:p>
-            <a:pPr algn="l"/>
-            <a:r>
-              <a:rPr sz="1200" b="1" i="0">
-                <a:solidFill>
-                  <a:srgbClr val="FFC107"/>
-                </a:solidFill>
-              </a:rPr>
-              <a:t>Downstream
-Task</a:t>
-            </a:r>
-          </a:p>
-        </p:txBody>
-      </p:sp>
-      <p:sp>
-        <p:nvSpPr>
-          <p:cNvPr id="25" name="TextBox 24"/>
-          <p:cNvSpPr txBox="1"/>
-          <p:nvPr/>
-        </p:nvSpPr>
-        <p:spPr>
-          <a:xfrm>
-            <a:off x="10030968" y="1709928"/>
-            <a:ext cx="2057400" cy="1463040"/>
-          </a:xfrm>
-          <a:prstGeom prst="rect">
-            <a:avLst/>
-          </a:prstGeom>
-          <a:noFill/>
-        </p:spPr>
-        <p:txBody>
-          <a:bodyPr wrap="square">
-            <a:spAutoFit/>
-          </a:bodyPr>
-          <a:lstStyle/>
-          <a:p>
-            <a:pPr algn="l"/>
-            <a:r>
-              <a:rPr sz="980" b="0" i="0">
+          <p:cNvPr id="21" name="TextBox 20"/>
+          <p:cNvSpPr txBox="1"/>
+          <p:nvPr/>
+        </p:nvSpPr>
+        <p:spPr>
+          <a:xfrm>
+            <a:off x="7580376" y="5596128"/>
+            <a:ext cx="2176272" cy="310896"/>
+          </a:xfrm>
+          <a:prstGeom prst="rect">
+            <a:avLst/>
+          </a:prstGeom>
+          <a:noFill/>
+        </p:spPr>
+        <p:txBody>
+          <a:bodyPr wrap="square">
+            <a:spAutoFit/>
+          </a:bodyPr>
+          <a:lstStyle/>
+          <a:p>
+            <a:pPr algn="l"/>
+            <a:r>
+              <a:rPr sz="1000" b="1" i="0">
+                <a:solidFill>
+                  <a:srgbClr val="45C4FF"/>
+                </a:solidFill>
+              </a:rPr>
+              <a:t>D  LLM cosine</a:t>
+            </a:r>
+          </a:p>
+        </p:txBody>
+      </p:sp>
+      <p:sp>
+        <p:nvSpPr>
+          <p:cNvPr id="22" name="TextBox 21"/>
+          <p:cNvSpPr txBox="1"/>
+          <p:nvPr/>
+        </p:nvSpPr>
+        <p:spPr>
+          <a:xfrm>
+            <a:off x="7580376" y="5925312"/>
+            <a:ext cx="2176272" cy="749808"/>
+          </a:xfrm>
+          <a:prstGeom prst="rect">
+            <a:avLst/>
+          </a:prstGeom>
+          <a:noFill/>
+        </p:spPr>
+        <p:txBody>
+          <a:bodyPr wrap="square">
+            <a:spAutoFit/>
+          </a:bodyPr>
+          <a:lstStyle/>
+          <a:p>
+            <a:pPr algn="l"/>
+            <a:r>
+              <a:rPr sz="880" b="0" i="1">
                 <a:solidFill>
                   <a:srgbClr val="FFFFFF"/>
                 </a:solidFill>
               </a:rPr>
-              <a:t>Node classification,
-link prediction,
-graph classification</a:t>
-            </a:r>
-          </a:p>
-        </p:txBody>
-      </p:sp>
-      <p:sp>
-        <p:nvSpPr>
-          <p:cNvPr id="26" name="Rectangle 25"/>
+              <a:t>1 − σ(cos(e_v, mean e_u))</a:t>
+            </a:r>
+          </a:p>
+        </p:txBody>
+      </p:sp>
+      <p:sp>
+        <p:nvSpPr>
+          <p:cNvPr id="23" name="Rectangle 22"/>
           <p:cNvSpPr/>
           <p:nvPr/>
         </p:nvSpPr>
         <p:spPr>
           <a:xfrm>
-            <a:off x="411480" y="3474720"/>
-            <a:ext cx="11338560" cy="1417320"/>
+            <a:off x="9793224" y="5596128"/>
+            <a:ext cx="54864" cy="1051560"/>
           </a:xfrm>
           <a:prstGeom prst="rect">
             <a:avLst/>
           </a:prstGeom>
           <a:solidFill>
-            <a:srgbClr val="101420"/>
+            <a:srgbClr val="2ECC71"/>
           </a:solidFill>
-          <a:ln w="10160">
-            <a:solidFill>
-              <a:srgbClr val="459BFF"/>
-            </a:solidFill>
+          <a:ln>
+            <a:noFill/>
           </a:ln>
         </p:spPr>
         <p:style>
@@ -10195,351 +10058,68 @@
       </p:sp>
       <p:sp>
         <p:nvSpPr>
-          <p:cNvPr id="27" name="TextBox 26"/>
-          <p:cNvSpPr txBox="1"/>
-          <p:nvPr/>
-        </p:nvSpPr>
-        <p:spPr>
-          <a:xfrm>
-            <a:off x="594360" y="3584448"/>
-            <a:ext cx="3657600" cy="347472"/>
-          </a:xfrm>
-          <a:prstGeom prst="rect">
-            <a:avLst/>
-          </a:prstGeom>
-          <a:noFill/>
-        </p:spPr>
-        <p:txBody>
-          <a:bodyPr wrap="square">
-            <a:spAutoFit/>
-          </a:bodyPr>
-          <a:lstStyle/>
-          <a:p>
-            <a:pPr algn="l"/>
-            <a:r>
-              <a:rPr sz="1200" b="1" i="0">
-                <a:solidFill>
-                  <a:srgbClr val="459BFF"/>
-                </a:solidFill>
-              </a:rPr>
-              <a:t>Formal update rule:</a:t>
-            </a:r>
-          </a:p>
-        </p:txBody>
-      </p:sp>
-      <p:sp>
-        <p:nvSpPr>
-          <p:cNvPr id="28" name="TextBox 27"/>
-          <p:cNvSpPr txBox="1"/>
-          <p:nvPr/>
-        </p:nvSpPr>
-        <p:spPr>
-          <a:xfrm>
-            <a:off x="594360" y="3977639"/>
-            <a:ext cx="10972800" cy="411480"/>
-          </a:xfrm>
-          <a:prstGeom prst="rect">
-            <a:avLst/>
-          </a:prstGeom>
-          <a:noFill/>
-        </p:spPr>
-        <p:txBody>
-          <a:bodyPr wrap="square">
-            <a:spAutoFit/>
-          </a:bodyPr>
-          <a:lstStyle/>
-          <a:p>
-            <a:pPr algn="ctr"/>
-            <a:r>
-              <a:rPr sz="1400" b="1" i="0">
-                <a:solidFill>
-                  <a:srgbClr val="45C4FF"/>
-                </a:solidFill>
-              </a:rPr>
-              <a:t>h_v  =  β_v · W_self(e_v)  +  (1−β_v) · W_neigh( MEAN({e_u : u ∈ N(v)}) )</a:t>
-            </a:r>
-          </a:p>
-        </p:txBody>
-      </p:sp>
-      <p:sp>
-        <p:nvSpPr>
-          <p:cNvPr id="29" name="TextBox 28"/>
-          <p:cNvSpPr txBox="1"/>
-          <p:nvPr/>
-        </p:nvSpPr>
-        <p:spPr>
-          <a:xfrm>
-            <a:off x="594360" y="4434840"/>
-            <a:ext cx="10972800" cy="347472"/>
-          </a:xfrm>
-          <a:prstGeom prst="rect">
-            <a:avLst/>
-          </a:prstGeom>
-          <a:noFill/>
-        </p:spPr>
-        <p:txBody>
-          <a:bodyPr wrap="square">
-            <a:spAutoFit/>
-          </a:bodyPr>
-          <a:lstStyle/>
-          <a:p>
-            <a:pPr algn="ctr"/>
-            <a:r>
-              <a:rPr sz="1050" b="0" i="0">
-                <a:solidFill>
-                  <a:srgbClr val="8A93A8"/>
-                </a:solidFill>
-              </a:rPr>
-              <a:t>β_v close to 1  →  trust self (ignore noisy neighbours)     β_v close to 0  →  trust neighbourhood (strong structural signal)</a:t>
-            </a:r>
-          </a:p>
-        </p:txBody>
-      </p:sp>
-      <p:sp>
-        <p:nvSpPr>
-          <p:cNvPr id="30" name="Rectangle 29"/>
-          <p:cNvSpPr/>
-          <p:nvPr/>
-        </p:nvSpPr>
-        <p:spPr>
-          <a:xfrm>
-            <a:off x="411480" y="5074920"/>
-            <a:ext cx="11338560" cy="1572768"/>
-          </a:xfrm>
-          <a:prstGeom prst="rect">
-            <a:avLst/>
-          </a:prstGeom>
-          <a:solidFill>
-            <a:srgbClr val="101420"/>
-          </a:solidFill>
-          <a:ln w="8890">
-            <a:solidFill>
-              <a:srgbClr val="353C50"/>
-            </a:solidFill>
-          </a:ln>
-        </p:spPr>
-        <p:style>
-          <a:lnRef idx="1">
-            <a:schemeClr val="accent1"/>
-          </a:lnRef>
-          <a:fillRef idx="3">
-            <a:schemeClr val="accent1"/>
-          </a:fillRef>
-          <a:effectRef idx="2">
-            <a:schemeClr val="accent1"/>
-          </a:effectRef>
-          <a:fontRef idx="minor">
-            <a:schemeClr val="lt1"/>
-          </a:fontRef>
-        </p:style>
-        <p:txBody>
-          <a:bodyPr rtlCol="0" anchor="ctr"/>
-          <a:lstStyle/>
-          <a:p>
-            <a:pPr algn="ctr"/>
-          </a:p>
-        </p:txBody>
-      </p:sp>
-      <p:sp>
-        <p:nvSpPr>
-          <p:cNvPr id="31" name="TextBox 30"/>
-          <p:cNvSpPr txBox="1"/>
-          <p:nvPr/>
-        </p:nvSpPr>
-        <p:spPr>
-          <a:xfrm>
-            <a:off x="594360" y="5166360"/>
-            <a:ext cx="4572000" cy="347472"/>
-          </a:xfrm>
-          <a:prstGeom prst="rect">
-            <a:avLst/>
-          </a:prstGeom>
-          <a:noFill/>
-        </p:spPr>
-        <p:txBody>
-          <a:bodyPr wrap="square">
-            <a:spAutoFit/>
-          </a:bodyPr>
-          <a:lstStyle/>
-          <a:p>
-            <a:pPr algn="l"/>
-            <a:r>
-              <a:rPr sz="1150" b="1" i="0">
+          <p:cNvPr id="24" name="TextBox 23"/>
+          <p:cNvSpPr txBox="1"/>
+          <p:nvPr/>
+        </p:nvSpPr>
+        <p:spPr>
+          <a:xfrm>
+            <a:off x="9902952" y="5596128"/>
+            <a:ext cx="2176272" cy="310896"/>
+          </a:xfrm>
+          <a:prstGeom prst="rect">
+            <a:avLst/>
+          </a:prstGeom>
+          <a:noFill/>
+        </p:spPr>
+        <p:txBody>
+          <a:bodyPr wrap="square">
+            <a:spAutoFit/>
+          </a:bodyPr>
+          <a:lstStyle/>
+          <a:p>
+            <a:pPr algn="l"/>
+            <a:r>
+              <a:rPr sz="1000" b="1" i="0">
+                <a:solidFill>
+                  <a:srgbClr val="2ECC71"/>
+                </a:solidFill>
+              </a:rPr>
+              <a:t>Proposed</a:t>
+            </a:r>
+          </a:p>
+        </p:txBody>
+      </p:sp>
+      <p:sp>
+        <p:nvSpPr>
+          <p:cNvPr id="25" name="TextBox 24"/>
+          <p:cNvSpPr txBox="1"/>
+          <p:nvPr/>
+        </p:nvSpPr>
+        <p:spPr>
+          <a:xfrm>
+            <a:off x="9902952" y="5925312"/>
+            <a:ext cx="2176272" cy="749808"/>
+          </a:xfrm>
+          <a:prstGeom prst="rect">
+            <a:avLst/>
+          </a:prstGeom>
+          <a:noFill/>
+        </p:spPr>
+        <p:txBody>
+          <a:bodyPr wrap="square">
+            <a:spAutoFit/>
+          </a:bodyPr>
+          <a:lstStyle/>
+          <a:p>
+            <a:pPr algn="l"/>
+            <a:r>
+              <a:rPr sz="880" b="0" i="1">
                 <a:solidFill>
                   <a:srgbClr val="FFFFFF"/>
                 </a:solidFill>
               </a:rPr>
-              <a:t>What β_v is in each variant:</a:t>
-            </a:r>
-          </a:p>
-        </p:txBody>
-      </p:sp>
-      <p:sp>
-        <p:nvSpPr>
-          <p:cNvPr id="32" name="TextBox 31"/>
-          <p:cNvSpPr txBox="1"/>
-          <p:nvPr/>
-        </p:nvSpPr>
-        <p:spPr>
-          <a:xfrm>
-            <a:off x="594360" y="5532120"/>
-            <a:ext cx="10972800" cy="292608"/>
-          </a:xfrm>
-          <a:prstGeom prst="rect">
-            <a:avLst/>
-          </a:prstGeom>
-          <a:noFill/>
-        </p:spPr>
-        <p:txBody>
-          <a:bodyPr wrap="square">
-            <a:spAutoFit/>
-          </a:bodyPr>
-          <a:lstStyle/>
-          <a:p>
-            <a:pPr algn="l"/>
-            <a:r>
-              <a:rPr sz="1000" b="0" i="0">
-                <a:solidFill>
-                  <a:srgbClr val="FF4D4D"/>
-                </a:solidFill>
-              </a:rPr>
-              <a:t>  A  Cosine          1 − σ( cos(h_v, mean h_u) )</a:t>
-            </a:r>
-          </a:p>
-        </p:txBody>
-      </p:sp>
-      <p:sp>
-        <p:nvSpPr>
-          <p:cNvPr id="33" name="TextBox 32"/>
-          <p:cNvSpPr txBox="1"/>
-          <p:nvPr/>
-        </p:nvSpPr>
-        <p:spPr>
-          <a:xfrm>
-            <a:off x="594360" y="5815584"/>
-            <a:ext cx="10972800" cy="292608"/>
-          </a:xfrm>
-          <a:prstGeom prst="rect">
-            <a:avLst/>
-          </a:prstGeom>
-          <a:noFill/>
-        </p:spPr>
-        <p:txBody>
-          <a:bodyPr wrap="square">
-            <a:spAutoFit/>
-          </a:bodyPr>
-          <a:lstStyle/>
-          <a:p>
-            <a:pPr algn="l"/>
-            <a:r>
-              <a:rPr sz="1000" b="0" i="0">
-                <a:solidFill>
-                  <a:srgbClr val="FF7F2A"/>
-                </a:solidFill>
-              </a:rPr>
-              <a:t>  B  Confidence      1 − mean[ max softmax(logits_u) ]</a:t>
-            </a:r>
-          </a:p>
-        </p:txBody>
-      </p:sp>
-      <p:sp>
-        <p:nvSpPr>
-          <p:cNvPr id="34" name="TextBox 33"/>
-          <p:cNvSpPr txBox="1"/>
-          <p:nvPr/>
-        </p:nvSpPr>
-        <p:spPr>
-          <a:xfrm>
-            <a:off x="594360" y="6099048"/>
-            <a:ext cx="10972800" cy="292608"/>
-          </a:xfrm>
-          <a:prstGeom prst="rect">
-            <a:avLst/>
-          </a:prstGeom>
-          <a:noFill/>
-        </p:spPr>
-        <p:txBody>
-          <a:bodyPr wrap="square">
-            <a:spAutoFit/>
-          </a:bodyPr>
-          <a:lstStyle/>
-          <a:p>
-            <a:pPr algn="l"/>
-            <a:r>
-              <a:rPr sz="1000" b="0" i="0">
-                <a:solidFill>
-                  <a:srgbClr val="A06CFF"/>
-                </a:solidFill>
-              </a:rPr>
-              <a:t>  C  Learned         MLP(e_v ‖ mean e_u).sigmoid()</a:t>
-            </a:r>
-          </a:p>
-        </p:txBody>
-      </p:sp>
-      <p:sp>
-        <p:nvSpPr>
-          <p:cNvPr id="35" name="TextBox 34"/>
-          <p:cNvSpPr txBox="1"/>
-          <p:nvPr/>
-        </p:nvSpPr>
-        <p:spPr>
-          <a:xfrm>
-            <a:off x="594360" y="6382512"/>
-            <a:ext cx="10972800" cy="292608"/>
-          </a:xfrm>
-          <a:prstGeom prst="rect">
-            <a:avLst/>
-          </a:prstGeom>
-          <a:noFill/>
-        </p:spPr>
-        <p:txBody>
-          <a:bodyPr wrap="square">
-            <a:spAutoFit/>
-          </a:bodyPr>
-          <a:lstStyle/>
-          <a:p>
-            <a:pPr algn="l"/>
-            <a:r>
-              <a:rPr sz="1000" b="0" i="0">
-                <a:solidFill>
-                  <a:srgbClr val="45C4FF"/>
-                </a:solidFill>
-              </a:rPr>
-              <a:t>  D  LLM cosine      1 − σ( cos(e_v, mean e_u) )   ← current impl</a:t>
-            </a:r>
-          </a:p>
-        </p:txBody>
-      </p:sp>
-      <p:sp>
-        <p:nvSpPr>
-          <p:cNvPr id="36" name="TextBox 35"/>
-          <p:cNvSpPr txBox="1"/>
-          <p:nvPr/>
-        </p:nvSpPr>
-        <p:spPr>
-          <a:xfrm>
-            <a:off x="594360" y="6665976"/>
-            <a:ext cx="10972800" cy="292608"/>
-          </a:xfrm>
-          <a:prstGeom prst="rect">
-            <a:avLst/>
-          </a:prstGeom>
-          <a:noFill/>
-        </p:spPr>
-        <p:txBody>
-          <a:bodyPr wrap="square">
-            <a:spAutoFit/>
-          </a:bodyPr>
-          <a:lstStyle/>
-          <a:p>
-            <a:pPr algn="l"/>
-            <a:r>
-              <a:rPr sz="1000" b="0" i="0">
-                <a:solidFill>
-                  <a:srgbClr val="2ECC71"/>
-                </a:solidFill>
-              </a:rPr>
-              <a:t>  Proposed           LLM(Q: 'is u relevant for v?') → β_v</a:t>
+              <a:t>LLM('is u relevant for v?') → β_v</a:t>
             </a:r>
           </a:p>
         </p:txBody>

</xml_diff>